<commit_message>
Correct model-specific trial counts in NarrativeQA slides
</commit_message>
<xml_diff>
--- a/slides/datasets-in-10-minutes-narrativeqa.pptx
+++ b/slides/datasets-in-10-minutes-narrativeqa.pptx
@@ -17642,7 +17642,7 @@
                 <a:ea typeface="Noto Sans CJK JP"/>
                 <a:cs typeface="Noto Sans"/>
               </a:rPr>
-              <a:t>v0.4.0、要約入力355問。各値は3試行平均、単位は%。</a:t>
+              <a:t>v0.4.0、要約入力355問。OPT・davinciは3試行平均、Llama 2は1試行。単位は%。</a:t>
             </a:r>
           </a:p>
         </p:txBody>
@@ -18343,7 +18343,7 @@
                 <a:ea typeface="Noto Sans CJK JP"/>
                 <a:cs typeface="Noto Sans"/>
               </a:rPr>
-              <a:t>入力上限に合わせて例を減らす。各実行のtest統計、3試行平均。</a:t>
+              <a:t>入力上限に合わせて例を減らす。test統計。OPT・davinciは3試行、Llama 2は1試行。</a:t>
             </a:r>
           </a:p>
         </p:txBody>
@@ -30740,7 +30740,7 @@
                 <a:ea typeface="Noto Sans CJK JP"/>
                 <a:cs typeface="Noto Sans"/>
               </a:rPr>
-              <a:t>最大提示例数5、提示例を選ぶ3試行、temperature 0、最大出力100トークン。</a:t>
+              <a:t>提示例は最大5例。OPT・davinciは3試行、Llama 2は1試行。</a:t>
             </a:r>
           </a:p>
           <a:p>
@@ -30770,7 +30770,7 @@
                 <a:ea typeface="Noto Sans CJK JP"/>
                 <a:cs typeface="Noto Sans"/>
               </a:rPr>
-              <a:t>表の値は未改変のtest指標。方言・人名などを変更した摂動の結果とは分けている。</a:t>
+              <a:t>temperature 0、最大出力100トークン。表は未改変のtest指標で、摂動の結果とは分けている。</a:t>
             </a:r>
           </a:p>
         </p:txBody>

</xml_diff>